<commit_message>
Added deployed app URL to presentation
</commit_message>
<xml_diff>
--- a/presentation/Supply_Chain_Sentinel_Design.pptx
+++ b/presentation/Supply_Chain_Sentinel_Design.pptx
@@ -1281,7 +1281,7 @@
           <a:p>
             <a:fld id="{5BCAD085-E8A6-8845-BD4E-CB4CCA059FC4}" type="datetimeFigureOut">
               <a:rPr lang="en-US" smtClean="0"/>
-              <a:t>6/24/26</a:t>
+              <a:t>6/30/26</a:t>
             </a:fld>
             <a:endParaRPr lang="en-US"/>
           </a:p>
@@ -1449,7 +1449,7 @@
           <a:p>
             <a:fld id="{5BCAD085-E8A6-8845-BD4E-CB4CCA059FC4}" type="datetimeFigureOut">
               <a:rPr lang="en-US" smtClean="0"/>
-              <a:t>6/24/26</a:t>
+              <a:t>6/30/26</a:t>
             </a:fld>
             <a:endParaRPr lang="en-US"/>
           </a:p>
@@ -1627,7 +1627,7 @@
           <a:p>
             <a:fld id="{5BCAD085-E8A6-8845-BD4E-CB4CCA059FC4}" type="datetimeFigureOut">
               <a:rPr lang="en-US" smtClean="0"/>
-              <a:t>6/24/26</a:t>
+              <a:t>6/30/26</a:t>
             </a:fld>
             <a:endParaRPr lang="en-US"/>
           </a:p>
@@ -1795,7 +1795,7 @@
           <a:p>
             <a:fld id="{5BCAD085-E8A6-8845-BD4E-CB4CCA059FC4}" type="datetimeFigureOut">
               <a:rPr lang="en-US" smtClean="0"/>
-              <a:t>6/24/26</a:t>
+              <a:t>6/30/26</a:t>
             </a:fld>
             <a:endParaRPr lang="en-US"/>
           </a:p>
@@ -2040,7 +2040,7 @@
           <a:p>
             <a:fld id="{5BCAD085-E8A6-8845-BD4E-CB4CCA059FC4}" type="datetimeFigureOut">
               <a:rPr lang="en-US" smtClean="0"/>
-              <a:t>6/24/26</a:t>
+              <a:t>6/30/26</a:t>
             </a:fld>
             <a:endParaRPr lang="en-US"/>
           </a:p>
@@ -2325,7 +2325,7 @@
           <a:p>
             <a:fld id="{5BCAD085-E8A6-8845-BD4E-CB4CCA059FC4}" type="datetimeFigureOut">
               <a:rPr lang="en-US" smtClean="0"/>
-              <a:t>6/24/26</a:t>
+              <a:t>6/30/26</a:t>
             </a:fld>
             <a:endParaRPr lang="en-US"/>
           </a:p>
@@ -2744,7 +2744,7 @@
           <a:p>
             <a:fld id="{5BCAD085-E8A6-8845-BD4E-CB4CCA059FC4}" type="datetimeFigureOut">
               <a:rPr lang="en-US" smtClean="0"/>
-              <a:t>6/24/26</a:t>
+              <a:t>6/30/26</a:t>
             </a:fld>
             <a:endParaRPr lang="en-US"/>
           </a:p>
@@ -2861,7 +2861,7 @@
           <a:p>
             <a:fld id="{5BCAD085-E8A6-8845-BD4E-CB4CCA059FC4}" type="datetimeFigureOut">
               <a:rPr lang="en-US" smtClean="0"/>
-              <a:t>6/24/26</a:t>
+              <a:t>6/30/26</a:t>
             </a:fld>
             <a:endParaRPr lang="en-US"/>
           </a:p>
@@ -2956,7 +2956,7 @@
           <a:p>
             <a:fld id="{5BCAD085-E8A6-8845-BD4E-CB4CCA059FC4}" type="datetimeFigureOut">
               <a:rPr lang="en-US" smtClean="0"/>
-              <a:t>6/24/26</a:t>
+              <a:t>6/30/26</a:t>
             </a:fld>
             <a:endParaRPr lang="en-US"/>
           </a:p>
@@ -3231,7 +3231,7 @@
           <a:p>
             <a:fld id="{5BCAD085-E8A6-8845-BD4E-CB4CCA059FC4}" type="datetimeFigureOut">
               <a:rPr lang="en-US" smtClean="0"/>
-              <a:t>6/24/26</a:t>
+              <a:t>6/30/26</a:t>
             </a:fld>
             <a:endParaRPr lang="en-US"/>
           </a:p>
@@ -3483,7 +3483,7 @@
           <a:p>
             <a:fld id="{5BCAD085-E8A6-8845-BD4E-CB4CCA059FC4}" type="datetimeFigureOut">
               <a:rPr lang="en-US" smtClean="0"/>
-              <a:t>6/24/26</a:t>
+              <a:t>6/30/26</a:t>
             </a:fld>
             <a:endParaRPr lang="en-US"/>
           </a:p>
@@ -3694,7 +3694,7 @@
           <a:p>
             <a:fld id="{5BCAD085-E8A6-8845-BD4E-CB4CCA059FC4}" type="datetimeFigureOut">
               <a:rPr lang="en-US" smtClean="0"/>
-              <a:t>6/24/26</a:t>
+              <a:t>6/30/26</a:t>
             </a:fld>
             <a:endParaRPr lang="en-US"/>
           </a:p>
@@ -13185,7 +13185,7 @@
         </p:nvSpPr>
         <p:spPr>
           <a:xfrm>
-            <a:off x="0" y="0"/>
+            <a:off x="0" y="237744"/>
             <a:ext cx="292608" cy="6858000"/>
           </a:xfrm>
           <a:prstGeom prst="rect">
@@ -13649,8 +13649,8 @@
         </p:nvSpPr>
         <p:spPr>
           <a:xfrm>
-            <a:off x="731520" y="5532120"/>
-            <a:ext cx="10698480" cy="685800"/>
+            <a:off x="731520" y="5568750"/>
+            <a:ext cx="10698480" cy="612540"/>
           </a:xfrm>
           <a:prstGeom prst="rect">
             <a:avLst/>
@@ -13672,7 +13672,7 @@
               </a:spcAft>
             </a:pPr>
             <a:r>
-              <a:rPr sz="1400" b="1">
+              <a:rPr sz="1400" b="1" dirty="0">
                 <a:solidFill>
                   <a:srgbClr val="6CB400"/>
                 </a:solidFill>
@@ -13681,14 +13681,76 @@
               <a:t>Outcome: </a:t>
             </a:r>
             <a:r>
-              <a:rPr sz="1400" b="0">
+              <a:rPr sz="1400" b="0" dirty="0">
                 <a:solidFill>
                   <a:srgbClr val="FFFFFF"/>
                 </a:solidFill>
                 <a:latin typeface="Calibri"/>
               </a:rPr>
-              <a:t>a CRITICAL risk caught about three weeks before the line would stop, with a committed plan and a full audit trail. Runs live: python run_demo.py --slow.</a:t>
-            </a:r>
+              <a:t>a CRITICAL risk caught about three weeks before the line would stop, with a committed plan and a full audit trail. </a:t>
+            </a:r>
+            <a:endParaRPr lang="de-CH" sz="1400" b="0" dirty="0">
+              <a:solidFill>
+                <a:srgbClr val="FFFFFF"/>
+              </a:solidFill>
+              <a:latin typeface="Calibri"/>
+            </a:endParaRPr>
+          </a:p>
+          <a:p>
+            <a:pPr>
+              <a:lnSpc>
+                <a:spcPct val="105000"/>
+              </a:lnSpc>
+              <a:spcAft>
+                <a:spcPts val="600"/>
+              </a:spcAft>
+            </a:pPr>
+            <a:r>
+              <a:rPr lang="de-CH" sz="1400" dirty="0">
+                <a:solidFill>
+                  <a:srgbClr val="FFFFFF"/>
+                </a:solidFill>
+              </a:rPr>
+              <a:t>App: https://</a:t>
+            </a:r>
+            <a:r>
+              <a:rPr lang="de-CH" sz="1400" dirty="0" err="1">
+                <a:solidFill>
+                  <a:srgbClr val="FFFFFF"/>
+                </a:solidFill>
+              </a:rPr>
+              <a:t>agentic</a:t>
+            </a:r>
+            <a:r>
+              <a:rPr lang="de-CH" sz="1400" dirty="0">
+                <a:solidFill>
+                  <a:srgbClr val="FFFFFF"/>
+                </a:solidFill>
+              </a:rPr>
+              <a:t>-ai-</a:t>
+            </a:r>
+            <a:r>
+              <a:rPr lang="de-CH" sz="1400" dirty="0" err="1">
+                <a:solidFill>
+                  <a:srgbClr val="FFFFFF"/>
+                </a:solidFill>
+              </a:rPr>
+              <a:t>sentinel.streamlit.app</a:t>
+            </a:r>
+            <a:r>
+              <a:rPr lang="de-CH" sz="1400" dirty="0">
+                <a:solidFill>
+                  <a:srgbClr val="FFFFFF"/>
+                </a:solidFill>
+              </a:rPr>
+              <a:t>/</a:t>
+            </a:r>
+            <a:endParaRPr sz="1400" b="0" dirty="0">
+              <a:solidFill>
+                <a:srgbClr val="FFFFFF"/>
+              </a:solidFill>
+              <a:latin typeface="Calibri"/>
+            </a:endParaRPr>
           </a:p>
         </p:txBody>
       </p:sp>

</xml_diff>